<commit_message>
Rename certification PCAP to PCAIP
The Python Institute already owns PCAP (Certified Associate in Python
Programming), so the Proxiant credential now abbreviates as PCAIP
(Proxiant Certified AI Professional); bootcamp tracks become
PCAIP-Agents and PCAIP-RAG. Full credential name, pricing, and exam
specs unchanged. Applied case-sensitively across all catalogues,
syllabi, certification tests, class notes, slides, indexes, README,
and generator sources; bootcamp docs regenerated (exam files now
PCAIP_*); Fundamentals PDFs regenerated. The lowercase packet-capture
"pcap" reference in the Week 9 networking lab is intentionally
untouched. Verified zero PCAP occurrences remain in text, filenames,
or sources.

Co-Authored-By: Claude Fable 5 <noreply@anthropic.com>
</commit_message>
<xml_diff>
--- a/AI Fundamentals Course/Week 4/Week4_Slides_GenAI_Ethics_Strategy.pptx
+++ b/AI Fundamentals Course/Week 4/Week4_Slides_GenAI_Ethics_Strategy.pptx
@@ -12053,7 +12053,7 @@
                   <a:srgbClr val="333333"/>
                 </a:solidFill>
               </a:rPr>
-              <a:t>• Certifications: PCAP (Python Programmer)</a:t>
+              <a:t>• Certifications: PCAIP (Python Programmer)</a:t>
             </a:r>
             <a:endParaRPr lang="en-US" sz="1400" dirty="0"/>
           </a:p>
@@ -12653,7 +12653,7 @@
                   <a:srgbClr val="333333"/>
                 </a:solidFill>
               </a:rPr>
-              <a:t>• PCAP: Python syntax, data structures, OOP, file handling</a:t>
+              <a:t>• PCAIP: Python syntax, data structures, OOP, file handling</a:t>
             </a:r>
             <a:endParaRPr lang="en-US" sz="1400" dirty="0"/>
           </a:p>

</xml_diff>